<commit_message>
add slide outline, refine narrative lines
</commit_message>
<xml_diff>
--- a/outputs/deck/UniSweet-FY2024-Review.pptx
+++ b/outputs/deck/UniSweet-FY2024-Review.pptx
@@ -15,6 +15,7 @@
     <p:sldId id="263" r:id="rId15"/>
     <p:sldId id="264" r:id="rId16"/>
     <p:sldId id="265" r:id="rId17"/>
+    <p:sldId id="266" r:id="rId18"/>
   </p:sldIdLst>
   <p:sldSz cx="12192000" cy="6858000" type="screen4x3"/>
   <p:notesSz cx="6858000" cy="9144000"/>
@@ -592,6 +593,93 @@
           <a:lstStyle/>
           <a:p>
             <a:r>
+              <a:t>Restore profitable growth without giving back the protected PBO.</a:t>
+            </a:r>
+          </a:p>
+          <a:p/>
+          <a:p>
+            <a:r>
+              <a:t>Each action has a first gate rather than a budget, so the decision today is to start, not to spend. Owners are named and the KPIs are already defined.</a:t>
+            </a:r>
+          </a:p>
+          <a:p/>
+          <a:p>
+            <a:r>
+              <a:t>[Sources]</a:t>
+            </a:r>
+          </a:p>
+          <a:p>
+            <a:r>
+              <a:t>- references/domain/calls-to-action-by-audience.md</a:t>
+            </a:r>
+          </a:p>
+        </p:txBody>
+      </p:sp>
+      <p:sp>
+        <p:nvSpPr>
+          <p:cNvPr id="4" name="Slide Number Placeholder 3"/>
+          <p:cNvSpPr>
+            <a:spLocks noGrp="1"/>
+          </p:cNvSpPr>
+          <p:nvPr>
+            <p:ph type="sldNum" idx="5" sz="quarter"/>
+          </p:nvPr>
+        </p:nvSpPr>
+        <p:spPr/>
+      </p:sp>
+    </p:spTree>
+  </p:cSld>
+  <p:clrMapOvr>
+    <a:masterClrMapping/>
+  </p:clrMapOvr>
+</p:notes>
+</file>
+
+<file path=ppt/notesSlides/notesSlide11.xml><?xml version="1.0" encoding="utf-8"?>
+<p:notes xmlns:a="http://schemas.openxmlformats.org/drawingml/2006/main" xmlns:p="http://schemas.openxmlformats.org/presentationml/2006/main" xmlns:r="http://schemas.openxmlformats.org/officeDocument/2006/relationships">
+  <p:cSld>
+    <p:spTree>
+      <p:nvGrpSpPr>
+        <p:cNvPr id="1" name=""/>
+        <p:cNvGrpSpPr/>
+        <p:nvPr/>
+      </p:nvGrpSpPr>
+      <p:grpSpPr>
+        <a:xfrm>
+          <a:off x="0" y="0"/>
+          <a:ext cx="0" cy="0"/>
+          <a:chOff x="0" y="0"/>
+          <a:chExt cx="0" cy="0"/>
+        </a:xfrm>
+      </p:grpSpPr>
+      <p:sp>
+        <p:nvSpPr>
+          <p:cNvPr id="2" name="Slide Image Placeholder 1"/>
+          <p:cNvSpPr>
+            <a:spLocks noGrp="1"/>
+          </p:cNvSpPr>
+          <p:nvPr>
+            <p:ph type="sldImg" idx="2"/>
+          </p:nvPr>
+        </p:nvSpPr>
+        <p:spPr/>
+      </p:sp>
+      <p:sp>
+        <p:nvSpPr>
+          <p:cNvPr id="3" name="Notes Placeholder 2"/>
+          <p:cNvSpPr>
+            <a:spLocks noGrp="1"/>
+          </p:cNvSpPr>
+          <p:nvPr>
+            <p:ph type="body" idx="3" sz="quarter"/>
+          </p:nvPr>
+        </p:nvSpPr>
+        <p:spPr/>
+        <p:txBody>
+          <a:bodyPr/>
+          <a:lstStyle/>
+          <a:p>
+            <a:r>
               <a:t>These are the qualifications I would give verbally. They are written down because this pack will be read by people I cannot qualify it for in person. Every chart has a matching CSV in outputs/report_visuals/data/.</a:t>
             </a:r>
           </a:p>
@@ -673,13 +761,13 @@
           <a:lstStyle/>
           <a:p>
             <a:r>
-              <a:t>PBO improved because cost fell faster than Gross Profit—not because growth recovered.</a:t>
+              <a:t>Six questions, six exhibits. Read the titles alone and you have the argument.</a:t>
             </a:r>
           </a:p>
           <a:p/>
           <a:p>
             <a:r>
-              <a:t>I am leading with the conclusion rather than walking you through the analysis. The six charts that follow are evidence for that one sentence.</a:t>
+              <a:t>Steps 1 and 2 establish how serious this is and whose problem it is. Steps 3 and 4 locate the damage and explain the profit result. Steps 5 and 6 are what we do about it.</a:t>
             </a:r>
           </a:p>
           <a:p/>
@@ -760,13 +848,13 @@
           <a:lstStyle/>
           <a:p>
             <a:r>
-              <a:t>Three KPIs, three adverse moves — and the discount rate made the last one worse.</a:t>
+              <a:t>Every favourable line in this year's P&amp;L is a cost line.</a:t>
             </a:r>
           </a:p>
           <a:p/>
           <a:p>
             <a:r>
-              <a:t>Turnover fell €19.6m and GSV €22.3m. Turnover fell the faster of the two because discount on Turnover rose 103bps at the same time.</a:t>
+              <a:t>I am leading with the conclusion rather than walking you through the analysis. The €15.5m taken out of marketing is larger than the €10.3m of Gross Profit lost — that gap, and nothing about demand, is why PBO is up.</a:t>
             </a:r>
           </a:p>
           <a:p/>
@@ -777,7 +865,7 @@
           </a:p>
           <a:p>
             <a:r>
-              <a:t>- P&amp;L Table.xlsx and outputs/sales_master.csv  |  Discount is stated on Turnover, the P&amp;L convention; on GSV the same movement reads 21.93% to 22.55% (+62bps)</a:t>
+              <a:t>- outputs/sales_master.csv, P&amp;L Table.xlsx and Market Report MAT Nov'24.xlsx</a:t>
             </a:r>
           </a:p>
         </p:txBody>
@@ -847,13 +935,13 @@
           <a:lstStyle/>
           <a:p>
             <a:r>
-              <a:t>No. The category fell 1.3% and we fell 4.3% — the gap is ours to explain.</a:t>
+              <a:t>Three KPIs, three adverse moves — and the discount rate made the last one worse.</a:t>
             </a:r>
           </a:p>
           <a:p/>
           <a:p>
             <a:r>
-              <a:t>Economy grew 17.7% and Premium 3.9%. The decline is Mainstream, which is where 79% of our turnover sits, and where we gave back 2.98 share points.</a:t>
+              <a:t>Turnover fell €19.6m and GSV €22.3m. Turnover fell the faster of the two because discount on Turnover rose 103bps at the same time.</a:t>
             </a:r>
           </a:p>
           <a:p/>
@@ -864,7 +952,7 @@
           </a:p>
           <a:p>
             <a:r>
-              <a:t>- Market Report MAT Nov'24.xlsx  |  Segment rows sum the named brands only, which cover 82.9% of Category; Category is the file's own total, not their sum</a:t>
+              <a:t>- P&amp;L Table.xlsx and outputs/sales_master.csv  |  Discount is stated on Turnover, the P&amp;L convention; on GSV the same movement reads 21.93% to 22.55% (+62bps)</a:t>
             </a:r>
           </a:p>
         </p:txBody>
@@ -934,13 +1022,13 @@
           <a:lstStyle/>
           <a:p>
             <a:r>
-              <a:t>Modern Trade. Same category decline, six times the share loss.</a:t>
+              <a:t>No. The category fell 1.3% and we fell 4.3% — the gap is ours to explain.</a:t>
             </a:r>
           </a:p>
           <a:p/>
           <a:p>
             <a:r>
-              <a:t>MT Mainstream fell 13.8% while MT Economy grew 41.4%, most of it LILAC at +5.53 points. DT lost only 0.28 share points against MT's 6.07.</a:t>
+              <a:t>Economy grew 17.7% and Premium 3.9%. The decline is Mainstream, which is where 79% of our turnover sits, and where we gave back 2.98 share points.</a:t>
             </a:r>
           </a:p>
           <a:p/>
@@ -951,7 +1039,7 @@
           </a:p>
           <a:p>
             <a:r>
-              <a:t>- Market Report MAT Nov'24.xlsx  |  Category growth is identical (-1.3%) at Total, DT and MT - the source scales it proportionally, so this row repeats page 2 by construction</a:t>
+              <a:t>- Market Report MAT Nov'24.xlsx  |  Segment rows sum the named brands only, which cover 82.9% of Category; Category is the file's own total, not their sum</a:t>
             </a:r>
           </a:p>
         </p:txBody>
@@ -1021,13 +1109,13 @@
           <a:lstStyle/>
           <a:p>
             <a:r>
-              <a:t>A second-half problem in one brand and one channel — which narrows the fix.</a:t>
+              <a:t>Modern Trade. Same category decline, six times the share loss.</a:t>
             </a:r>
           </a:p>
           <a:p/>
           <a:p>
             <a:r>
-              <a:t>H1 was down €2.99m, H2 down €5.74m. November is the only month above FY2023. Monthly sell-in does not by itself establish seasonality.</a:t>
+              <a:t>MT Mainstream fell 13.8% while MT Economy grew 41.4%, most of it LILAC at +5.53 points. DT lost only 0.28 share points against MT's 6.07.</a:t>
             </a:r>
           </a:p>
           <a:p/>
@@ -1038,7 +1126,7 @@
           </a:p>
           <a:p>
             <a:r>
-              <a:t>- outputs/sales_master.csv  |  Internal sell-in GSV on the raw reporting base; monthly weakness does not by itself establish seasonality</a:t>
+              <a:t>- Market Report MAT Nov'24.xlsx  |  Category growth is identical (-1.3%) at Total, DT and MT - the source scales it proportionally, so this row repeats page 2 by construction</a:t>
             </a:r>
           </a:p>
         </p:txBody>
@@ -1108,13 +1196,13 @@
           <a:lstStyle/>
           <a:p>
             <a:r>
-              <a:t>PBO protection is cost-led. It is repeatable once, maybe twice.</a:t>
+              <a:t>A second-half problem in one brand and one channel — which narrows the fix.</a:t>
             </a:r>
           </a:p>
           <a:p/>
           <a:p>
             <a:r>
-              <a:t>OLIVE marketing fell 30% and supply chain 5%. Supply chain cost per euro of Turnover still worsened 35bps, so this is a smaller base, not efficiency.</a:t>
+              <a:t>H1 was down €2.99m, H2 down €5.74m. November is the only month above FY2023. Monthly sell-in does not by itself establish seasonality.</a:t>
             </a:r>
           </a:p>
           <a:p/>
@@ -1125,7 +1213,7 @@
           </a:p>
           <a:p>
             <a:r>
-              <a:t>- P&amp;L Table.xlsx  |  Marketing and supply chain cost are P&amp;L assumptions stated in the source workbook, not measured spend</a:t>
+              <a:t>- outputs/sales_master.csv  |  Internal sell-in GSV on the raw reporting base; monthly weakness does not by itself establish seasonality</a:t>
             </a:r>
           </a:p>
         </p:txBody>
@@ -1195,13 +1283,13 @@
           <a:lstStyle/>
           <a:p>
             <a:r>
-              <a:t>One brand to scale on evidence, one to diagnose before funding.</a:t>
+              <a:t>PBO protection is cost-led. It is repeatable once, maybe twice.</a:t>
             </a:r>
           </a:p>
           <a:p/>
           <a:p>
             <a:r>
-              <a:t>COBALT grew 11.6% against a market up 3.9% and gained 0.56 share points. SKY fell 7.4% while its market grew 23.8% — reconcile that before spending.</a:t>
+              <a:t>OLIVE marketing fell 30% and supply chain 5%. Supply chain cost per euro of Turnover still worsened 35bps, so this is a smaller base, not efficiency.</a:t>
             </a:r>
           </a:p>
           <a:p/>
@@ -1212,7 +1300,7 @@
           </a:p>
           <a:p>
             <a:r>
-              <a:t>- P&amp;L Table.xlsx and Market Report MAT Nov'24.xlsx  |  Internal Turnover is FY sell-in; market value is MAT Nov'24 sell-out - different periods and different measures</a:t>
+              <a:t>- P&amp;L Table.xlsx  |  Marketing and supply chain cost are P&amp;L assumptions stated in the source workbook, not measured spend</a:t>
             </a:r>
           </a:p>
         </p:txBody>
@@ -1282,13 +1370,13 @@
           <a:lstStyle/>
           <a:p>
             <a:r>
-              <a:t>Restore profitable growth without giving back the protected PBO.</a:t>
+              <a:t>One brand to scale on evidence, one to diagnose before funding.</a:t>
             </a:r>
           </a:p>
           <a:p/>
           <a:p>
             <a:r>
-              <a:t>Each action has a first gate rather than a budget, so the decision today is to start, not to spend. Owners are named and the KPIs are already defined.</a:t>
+              <a:t>COBALT grew 11.6% against a market up 3.9% and gained 0.56 share points. SKY fell 7.4% while its market grew 23.8% — reconcile that before spending.</a:t>
             </a:r>
           </a:p>
           <a:p/>
@@ -1299,7 +1387,7 @@
           </a:p>
           <a:p>
             <a:r>
-              <a:t>- references/domain/calls-to-action-by-audience.md</a:t>
+              <a:t>- P&amp;L Table.xlsx and Market Report MAT Nov'24.xlsx  |  Internal Turnover is FY sell-in; market value is MAT Nov'24 sell-out - different periods and different measures</a:t>
             </a:r>
           </a:p>
         </p:txBody>
@@ -4490,6 +4578,453 @@
                 </a:solidFill>
                 <a:latin typeface="Arial"/>
               </a:rPr>
+              <a:t>THE ASK</a:t>
+            </a:r>
+          </a:p>
+        </p:txBody>
+      </p:sp>
+      <p:sp>
+        <p:nvSpPr>
+          <p:cNvPr id="3" name="TextBox 2"/>
+          <p:cNvSpPr txBox="1"/>
+          <p:nvPr/>
+        </p:nvSpPr>
+        <p:spPr>
+          <a:xfrm>
+            <a:off x="670560" y="411480"/>
+            <a:ext cx="10850879" cy="822960"/>
+          </a:xfrm>
+          <a:prstGeom prst="rect">
+            <a:avLst/>
+          </a:prstGeom>
+          <a:noFill/>
+        </p:spPr>
+        <p:txBody>
+          <a:bodyPr wrap="square" lIns="0" rIns="0" tIns="0" bIns="0">
+            <a:spAutoFit/>
+          </a:bodyPr>
+          <a:lstStyle/>
+          <a:p>
+            <a:pPr>
+              <a:lnSpc>
+                <a:spcPct val="115000"/>
+              </a:lnSpc>
+            </a:pPr>
+            <a:r>
+              <a:rPr sz="2300" b="1">
+                <a:solidFill>
+                  <a:srgbClr val="004C6D"/>
+                </a:solidFill>
+                <a:latin typeface="Arial"/>
+              </a:rPr>
+              <a:t>Approve the three week-0 gates today</a:t>
+            </a:r>
+          </a:p>
+        </p:txBody>
+      </p:sp>
+      <p:sp>
+        <p:nvSpPr>
+          <p:cNvPr id="4" name="TextBox 3"/>
+          <p:cNvSpPr txBox="1"/>
+          <p:nvPr/>
+        </p:nvSpPr>
+        <p:spPr>
+          <a:xfrm>
+            <a:off x="670560" y="1645919"/>
+            <a:ext cx="10850879" cy="256032"/>
+          </a:xfrm>
+          <a:prstGeom prst="rect">
+            <a:avLst/>
+          </a:prstGeom>
+          <a:noFill/>
+        </p:spPr>
+        <p:txBody>
+          <a:bodyPr wrap="square" lIns="0" rIns="0" tIns="0" bIns="0">
+            <a:spAutoFit/>
+          </a:bodyPr>
+          <a:lstStyle/>
+          <a:p>
+            <a:pPr>
+              <a:lnSpc>
+                <a:spcPct val="115000"/>
+              </a:lnSpc>
+            </a:pPr>
+            <a:r>
+              <a:rPr sz="1200" b="1">
+                <a:solidFill>
+                  <a:srgbClr val="004C6D"/>
+                </a:solidFill>
+                <a:latin typeface="Arial"/>
+              </a:rPr>
+              <a:t>ACTION 1  ·  SALES HEAD</a:t>
+            </a:r>
+          </a:p>
+        </p:txBody>
+      </p:sp>
+      <p:sp>
+        <p:nvSpPr>
+          <p:cNvPr id="5" name="TextBox 4"/>
+          <p:cNvSpPr txBox="1"/>
+          <p:nvPr/>
+        </p:nvSpPr>
+        <p:spPr>
+          <a:xfrm>
+            <a:off x="670560" y="1901952"/>
+            <a:ext cx="10850879" cy="475488"/>
+          </a:xfrm>
+          <a:prstGeom prst="rect">
+            <a:avLst/>
+          </a:prstGeom>
+          <a:noFill/>
+        </p:spPr>
+        <p:txBody>
+          <a:bodyPr wrap="square" lIns="0" rIns="0" tIns="0" bIns="0">
+            <a:spAutoFit/>
+          </a:bodyPr>
+          <a:lstStyle/>
+          <a:p>
+            <a:pPr>
+              <a:lnSpc>
+                <a:spcPct val="125000"/>
+              </a:lnSpc>
+            </a:pPr>
+            <a:r>
+              <a:rPr sz="1400" b="0">
+                <a:solidFill>
+                  <a:srgbClr val="262626"/>
+                </a:solidFill>
+                <a:latin typeface="Arial"/>
+              </a:rPr>
+              <a:t>Approve the OLIVE × Modern Trade recovery baseline and its customer × SKU economics, weeks 0-2.</a:t>
+            </a:r>
+          </a:p>
+        </p:txBody>
+      </p:sp>
+      <p:sp>
+        <p:nvSpPr>
+          <p:cNvPr id="6" name="TextBox 5"/>
+          <p:cNvSpPr txBox="1"/>
+          <p:nvPr/>
+        </p:nvSpPr>
+        <p:spPr>
+          <a:xfrm>
+            <a:off x="670560" y="2487168"/>
+            <a:ext cx="10850879" cy="256032"/>
+          </a:xfrm>
+          <a:prstGeom prst="rect">
+            <a:avLst/>
+          </a:prstGeom>
+          <a:noFill/>
+        </p:spPr>
+        <p:txBody>
+          <a:bodyPr wrap="square" lIns="0" rIns="0" tIns="0" bIns="0">
+            <a:spAutoFit/>
+          </a:bodyPr>
+          <a:lstStyle/>
+          <a:p>
+            <a:pPr>
+              <a:lnSpc>
+                <a:spcPct val="115000"/>
+              </a:lnSpc>
+            </a:pPr>
+            <a:r>
+              <a:rPr sz="1200" b="1">
+                <a:solidFill>
+                  <a:srgbClr val="004C6D"/>
+                </a:solidFill>
+                <a:latin typeface="Arial"/>
+              </a:rPr>
+              <a:t>ACTION 2  ·  SALES HEAD</a:t>
+            </a:r>
+          </a:p>
+        </p:txBody>
+      </p:sp>
+      <p:sp>
+        <p:nvSpPr>
+          <p:cNvPr id="7" name="TextBox 6"/>
+          <p:cNvSpPr txBox="1"/>
+          <p:nvPr/>
+        </p:nvSpPr>
+        <p:spPr>
+          <a:xfrm>
+            <a:off x="670560" y="2743200"/>
+            <a:ext cx="10850879" cy="475488"/>
+          </a:xfrm>
+          <a:prstGeom prst="rect">
+            <a:avLst/>
+          </a:prstGeom>
+          <a:noFill/>
+        </p:spPr>
+        <p:txBody>
+          <a:bodyPr wrap="square" lIns="0" rIns="0" tIns="0" bIns="0">
+            <a:spAutoFit/>
+          </a:bodyPr>
+          <a:lstStyle/>
+          <a:p>
+            <a:pPr>
+              <a:lnSpc>
+                <a:spcPct val="125000"/>
+              </a:lnSpc>
+            </a:pPr>
+            <a:r>
+              <a:rPr sz="1400" b="0">
+                <a:solidFill>
+                  <a:srgbClr val="262626"/>
+                </a:solidFill>
+                <a:latin typeface="Arial"/>
+              </a:rPr>
+              <a:t>Approve classifying trade spend into keep, test, redesign or stop before any budget is restored.</a:t>
+            </a:r>
+          </a:p>
+        </p:txBody>
+      </p:sp>
+      <p:sp>
+        <p:nvSpPr>
+          <p:cNvPr id="8" name="TextBox 7"/>
+          <p:cNvSpPr txBox="1"/>
+          <p:nvPr/>
+        </p:nvSpPr>
+        <p:spPr>
+          <a:xfrm>
+            <a:off x="670560" y="3328415"/>
+            <a:ext cx="10850879" cy="256032"/>
+          </a:xfrm>
+          <a:prstGeom prst="rect">
+            <a:avLst/>
+          </a:prstGeom>
+          <a:noFill/>
+        </p:spPr>
+        <p:txBody>
+          <a:bodyPr wrap="square" lIns="0" rIns="0" tIns="0" bIns="0">
+            <a:spAutoFit/>
+          </a:bodyPr>
+          <a:lstStyle/>
+          <a:p>
+            <a:pPr>
+              <a:lnSpc>
+                <a:spcPct val="115000"/>
+              </a:lnSpc>
+            </a:pPr>
+            <a:r>
+              <a:rPr sz="1200" b="1">
+                <a:solidFill>
+                  <a:srgbClr val="004C6D"/>
+                </a:solidFill>
+                <a:latin typeface="Arial"/>
+              </a:rPr>
+              <a:t>ACTION 3  ·  FINANCE HEAD</a:t>
+            </a:r>
+          </a:p>
+        </p:txBody>
+      </p:sp>
+      <p:sp>
+        <p:nvSpPr>
+          <p:cNvPr id="9" name="TextBox 8"/>
+          <p:cNvSpPr txBox="1"/>
+          <p:nvPr/>
+        </p:nvSpPr>
+        <p:spPr>
+          <a:xfrm>
+            <a:off x="670560" y="3584448"/>
+            <a:ext cx="10850879" cy="475488"/>
+          </a:xfrm>
+          <a:prstGeom prst="rect">
+            <a:avLst/>
+          </a:prstGeom>
+          <a:noFill/>
+        </p:spPr>
+        <p:txBody>
+          <a:bodyPr wrap="square" lIns="0" rIns="0" tIns="0" bIns="0">
+            <a:spAutoFit/>
+          </a:bodyPr>
+          <a:lstStyle/>
+          <a:p>
+            <a:pPr>
+              <a:lnSpc>
+                <a:spcPct val="125000"/>
+              </a:lnSpc>
+            </a:pPr>
+            <a:r>
+              <a:rPr sz="1400" b="0">
+                <a:solidFill>
+                  <a:srgbClr val="262626"/>
+                </a:solidFill>
+                <a:latin typeface="Arial"/>
+              </a:rPr>
+              <a:t>Agree scale funding is released only after positive incremental Gross Profit — COBALT first, SKY only after diagnosis.</a:t>
+            </a:r>
+          </a:p>
+        </p:txBody>
+      </p:sp>
+      <p:sp>
+        <p:nvSpPr>
+          <p:cNvPr id="10" name="TextBox 9"/>
+          <p:cNvSpPr txBox="1"/>
+          <p:nvPr/>
+        </p:nvSpPr>
+        <p:spPr>
+          <a:xfrm>
+            <a:off x="670560" y="4169664"/>
+            <a:ext cx="10850879" cy="256032"/>
+          </a:xfrm>
+          <a:prstGeom prst="rect">
+            <a:avLst/>
+          </a:prstGeom>
+          <a:noFill/>
+        </p:spPr>
+        <p:txBody>
+          <a:bodyPr wrap="square" lIns="0" rIns="0" tIns="0" bIns="0">
+            <a:spAutoFit/>
+          </a:bodyPr>
+          <a:lstStyle/>
+          <a:p>
+            <a:pPr>
+              <a:lnSpc>
+                <a:spcPct val="115000"/>
+              </a:lnSpc>
+            </a:pPr>
+            <a:r>
+              <a:rPr sz="1200" b="1">
+                <a:solidFill>
+                  <a:srgbClr val="004C6D"/>
+                </a:solidFill>
+                <a:latin typeface="Arial"/>
+              </a:rPr>
+              <a:t>IF WE DO NOTHING</a:t>
+            </a:r>
+          </a:p>
+        </p:txBody>
+      </p:sp>
+      <p:sp>
+        <p:nvSpPr>
+          <p:cNvPr id="11" name="TextBox 10"/>
+          <p:cNvSpPr txBox="1"/>
+          <p:nvPr/>
+        </p:nvSpPr>
+        <p:spPr>
+          <a:xfrm>
+            <a:off x="670560" y="4425696"/>
+            <a:ext cx="10850879" cy="475488"/>
+          </a:xfrm>
+          <a:prstGeom prst="rect">
+            <a:avLst/>
+          </a:prstGeom>
+          <a:noFill/>
+        </p:spPr>
+        <p:txBody>
+          <a:bodyPr wrap="square" lIns="0" rIns="0" tIns="0" bIns="0">
+            <a:spAutoFit/>
+          </a:bodyPr>
+          <a:lstStyle/>
+          <a:p>
+            <a:pPr>
+              <a:lnSpc>
+                <a:spcPct val="125000"/>
+              </a:lnSpc>
+            </a:pPr>
+            <a:r>
+              <a:rPr sz="1400" b="0">
+                <a:solidFill>
+                  <a:srgbClr val="262626"/>
+                </a:solidFill>
+                <a:latin typeface="Arial"/>
+              </a:rPr>
+              <a:t>The marketing lever cannot be pulled twice; FY2025 PBO carries the full topline decline.</a:t>
+            </a:r>
+          </a:p>
+        </p:txBody>
+      </p:sp>
+      <p:sp>
+        <p:nvSpPr>
+          <p:cNvPr id="12" name="TextBox 11"/>
+          <p:cNvSpPr txBox="1"/>
+          <p:nvPr/>
+        </p:nvSpPr>
+        <p:spPr>
+          <a:xfrm>
+            <a:off x="670560" y="6469380"/>
+            <a:ext cx="10850879" cy="182880"/>
+          </a:xfrm>
+          <a:prstGeom prst="rect">
+            <a:avLst/>
+          </a:prstGeom>
+          <a:noFill/>
+        </p:spPr>
+        <p:txBody>
+          <a:bodyPr wrap="square" lIns="0" rIns="0" tIns="0" bIns="0">
+            <a:spAutoFit/>
+          </a:bodyPr>
+          <a:lstStyle/>
+          <a:p>
+            <a:pPr>
+              <a:lnSpc>
+                <a:spcPct val="115000"/>
+              </a:lnSpc>
+            </a:pPr>
+            <a:r>
+              <a:rPr sz="850" b="0">
+                <a:solidFill>
+                  <a:srgbClr val="BFBFBF"/>
+                </a:solidFill>
+                <a:latin typeface="Arial"/>
+              </a:rPr>
+              <a:t>Source: references/domain/calls-to-action-by-audience.md</a:t>
+            </a:r>
+          </a:p>
+        </p:txBody>
+      </p:sp>
+    </p:spTree>
+  </p:cSld>
+  <p:clrMapOvr>
+    <a:masterClrMapping/>
+  </p:clrMapOvr>
+</p:sld>
+</file>
+
+<file path=ppt/slides/slide11.xml><?xml version="1.0" encoding="utf-8"?>
+<p:sld xmlns:a="http://schemas.openxmlformats.org/drawingml/2006/main" xmlns:p="http://schemas.openxmlformats.org/presentationml/2006/main" xmlns:r="http://schemas.openxmlformats.org/officeDocument/2006/relationships">
+  <p:cSld>
+    <p:spTree>
+      <p:nvGrpSpPr>
+        <p:cNvPr id="1" name=""/>
+        <p:cNvGrpSpPr/>
+        <p:nvPr/>
+      </p:nvGrpSpPr>
+      <p:grpSpPr/>
+      <p:sp>
+        <p:nvSpPr>
+          <p:cNvPr id="2" name="TextBox 1"/>
+          <p:cNvSpPr txBox="1"/>
+          <p:nvPr/>
+        </p:nvSpPr>
+        <p:spPr>
+          <a:xfrm>
+            <a:off x="670560" y="137160"/>
+            <a:ext cx="10850879" cy="228600"/>
+          </a:xfrm>
+          <a:prstGeom prst="rect">
+            <a:avLst/>
+          </a:prstGeom>
+          <a:noFill/>
+        </p:spPr>
+        <p:txBody>
+          <a:bodyPr wrap="square" lIns="0" rIns="0" tIns="0" bIns="0">
+            <a:spAutoFit/>
+          </a:bodyPr>
+          <a:lstStyle/>
+          <a:p>
+            <a:pPr>
+              <a:lnSpc>
+                <a:spcPct val="115000"/>
+              </a:lnSpc>
+            </a:pPr>
+            <a:r>
+              <a:rPr sz="950" b="1">
+                <a:solidFill>
+                  <a:srgbClr val="BFBFBF"/>
+                </a:solidFill>
+                <a:latin typeface="Arial"/>
+              </a:rPr>
               <a:t>APPENDIX  |  HOW TO READ THIS PACK</a:t>
             </a:r>
           </a:p>
@@ -5015,7 +5550,7 @@
                 </a:solidFill>
                 <a:latin typeface="Arial"/>
               </a:rPr>
-              <a:t>THE ANSWER, UP FRONT</a:t>
+              <a:t>THE ROUTE</a:t>
             </a:r>
           </a:p>
         </p:txBody>
@@ -5054,7 +5589,7 @@
                 </a:solidFill>
                 <a:latin typeface="Arial"/>
               </a:rPr>
-              <a:t>Profit rose, but the business did not get healthier</a:t>
+              <a:t>The argument runs in six steps, and the answer comes first</a:t>
             </a:r>
           </a:p>
         </p:txBody>
@@ -5067,8 +5602,8 @@
         </p:nvSpPr>
         <p:spPr>
           <a:xfrm>
-            <a:off x="670560" y="1783080"/>
-            <a:ext cx="10850879" cy="2194560"/>
+            <a:off x="670560" y="1645919"/>
+            <a:ext cx="10850879" cy="256032"/>
           </a:xfrm>
           <a:prstGeom prst="rect">
             <a:avLst/>
@@ -5083,17 +5618,17 @@
           <a:p>
             <a:pPr>
               <a:lnSpc>
-                <a:spcPct val="130000"/>
+                <a:spcPct val="115000"/>
               </a:lnSpc>
             </a:pPr>
             <a:r>
-              <a:rPr sz="2600" b="1">
-                <a:solidFill>
-                  <a:srgbClr val="262626"/>
+              <a:rPr sz="1200" b="1">
+                <a:solidFill>
+                  <a:srgbClr val="595959"/>
                 </a:solidFill>
                 <a:latin typeface="Arial"/>
               </a:rPr>
-              <a:t>Topline and share fell; lower spend alone protected PBO.</a:t>
+              <a:t>1  ·  HOW BAD IS IT?</a:t>
             </a:r>
           </a:p>
         </p:txBody>
@@ -5106,8 +5641,8 @@
         </p:nvSpPr>
         <p:spPr>
           <a:xfrm>
-            <a:off x="670560" y="4160520"/>
-            <a:ext cx="10850879" cy="731520"/>
+            <a:off x="670560" y="1901952"/>
+            <a:ext cx="10850879" cy="475488"/>
           </a:xfrm>
           <a:prstGeom prst="rect">
             <a:avLst/>
@@ -5122,17 +5657,17 @@
           <a:p>
             <a:pPr>
               <a:lnSpc>
-                <a:spcPct val="145000"/>
+                <a:spcPct val="125000"/>
               </a:lnSpc>
             </a:pPr>
             <a:r>
-              <a:rPr sz="1300" b="0">
-                <a:solidFill>
-                  <a:srgbClr val="595959"/>
+              <a:rPr sz="1400" b="0">
+                <a:solidFill>
+                  <a:srgbClr val="262626"/>
                 </a:solidFill>
                 <a:latin typeface="Arial"/>
               </a:rPr>
-              <a:t>Restore profitable growth without giving back the protected profit.</a:t>
+              <a:t>Turnover, GSV and discount intensity — the three topline KPIs, FY2024 against FY2023.</a:t>
             </a:r>
           </a:p>
         </p:txBody>
@@ -5145,8 +5680,8 @@
         </p:nvSpPr>
         <p:spPr>
           <a:xfrm>
-            <a:off x="670560" y="4672584"/>
-            <a:ext cx="10850879" cy="731520"/>
+            <a:off x="670560" y="2487168"/>
+            <a:ext cx="10850879" cy="256032"/>
           </a:xfrm>
           <a:prstGeom prst="rect">
             <a:avLst/>
@@ -5161,17 +5696,17 @@
           <a:p>
             <a:pPr>
               <a:lnSpc>
-                <a:spcPct val="145000"/>
+                <a:spcPct val="115000"/>
               </a:lnSpc>
             </a:pPr>
             <a:r>
-              <a:rPr sz="1300" b="0">
+              <a:rPr sz="1200" b="1">
                 <a:solidFill>
                   <a:srgbClr val="595959"/>
                 </a:solidFill>
                 <a:latin typeface="Arial"/>
               </a:rPr>
-              <a:t>How bad is it?  →  Did the market do this to us?  →  Where exactly did it break?  →  Why did PBO still rise?  →  What is left to grow?</a:t>
+              <a:t>2  ·  DID THE MARKET DO THIS TO US?</a:t>
             </a:r>
           </a:p>
         </p:txBody>
@@ -5179,6 +5714,357 @@
       <p:sp>
         <p:nvSpPr>
           <p:cNvPr id="7" name="TextBox 6"/>
+          <p:cNvSpPr txBox="1"/>
+          <p:nvPr/>
+        </p:nvSpPr>
+        <p:spPr>
+          <a:xfrm>
+            <a:off x="670560" y="2743200"/>
+            <a:ext cx="10850879" cy="475488"/>
+          </a:xfrm>
+          <a:prstGeom prst="rect">
+            <a:avLst/>
+          </a:prstGeom>
+          <a:noFill/>
+        </p:spPr>
+        <p:txBody>
+          <a:bodyPr wrap="square" lIns="0" rIns="0" tIns="0" bIns="0">
+            <a:spAutoFit/>
+          </a:bodyPr>
+          <a:lstStyle/>
+          <a:p>
+            <a:pPr>
+              <a:lnSpc>
+                <a:spcPct val="125000"/>
+              </a:lnSpc>
+            </a:pPr>
+            <a:r>
+              <a:rPr sz="1400" b="0">
+                <a:solidFill>
+                  <a:srgbClr val="262626"/>
+                </a:solidFill>
+                <a:latin typeface="Arial"/>
+              </a:rPr>
+              <a:t>Category and segment growth, to separate what happened to everyone from what happened to us.</a:t>
+            </a:r>
+          </a:p>
+        </p:txBody>
+      </p:sp>
+      <p:sp>
+        <p:nvSpPr>
+          <p:cNvPr id="8" name="TextBox 7"/>
+          <p:cNvSpPr txBox="1"/>
+          <p:nvPr/>
+        </p:nvSpPr>
+        <p:spPr>
+          <a:xfrm>
+            <a:off x="670560" y="3328415"/>
+            <a:ext cx="10850879" cy="256032"/>
+          </a:xfrm>
+          <a:prstGeom prst="rect">
+            <a:avLst/>
+          </a:prstGeom>
+          <a:noFill/>
+        </p:spPr>
+        <p:txBody>
+          <a:bodyPr wrap="square" lIns="0" rIns="0" tIns="0" bIns="0">
+            <a:spAutoFit/>
+          </a:bodyPr>
+          <a:lstStyle/>
+          <a:p>
+            <a:pPr>
+              <a:lnSpc>
+                <a:spcPct val="115000"/>
+              </a:lnSpc>
+            </a:pPr>
+            <a:r>
+              <a:rPr sz="1200" b="1">
+                <a:solidFill>
+                  <a:srgbClr val="595959"/>
+                </a:solidFill>
+                <a:latin typeface="Arial"/>
+              </a:rPr>
+              <a:t>3  ·  WHERE EXACTLY DID IT BREAK?</a:t>
+            </a:r>
+          </a:p>
+        </p:txBody>
+      </p:sp>
+      <p:sp>
+        <p:nvSpPr>
+          <p:cNvPr id="9" name="TextBox 8"/>
+          <p:cNvSpPr txBox="1"/>
+          <p:nvPr/>
+        </p:nvSpPr>
+        <p:spPr>
+          <a:xfrm>
+            <a:off x="670560" y="3584448"/>
+            <a:ext cx="10850879" cy="475488"/>
+          </a:xfrm>
+          <a:prstGeom prst="rect">
+            <a:avLst/>
+          </a:prstGeom>
+          <a:noFill/>
+        </p:spPr>
+        <p:txBody>
+          <a:bodyPr wrap="square" lIns="0" rIns="0" tIns="0" bIns="0">
+            <a:spAutoFit/>
+          </a:bodyPr>
+          <a:lstStyle/>
+          <a:p>
+            <a:pPr>
+              <a:lnSpc>
+                <a:spcPct val="125000"/>
+              </a:lnSpc>
+            </a:pPr>
+            <a:r>
+              <a:rPr sz="1400" b="0">
+                <a:solidFill>
+                  <a:srgbClr val="262626"/>
+                </a:solidFill>
+                <a:latin typeface="Arial"/>
+              </a:rPr>
+              <a:t>Down to the channel, then to one brand in that channel, month by month.</a:t>
+            </a:r>
+          </a:p>
+        </p:txBody>
+      </p:sp>
+      <p:sp>
+        <p:nvSpPr>
+          <p:cNvPr id="10" name="TextBox 9"/>
+          <p:cNvSpPr txBox="1"/>
+          <p:nvPr/>
+        </p:nvSpPr>
+        <p:spPr>
+          <a:xfrm>
+            <a:off x="670560" y="4169664"/>
+            <a:ext cx="10850879" cy="256032"/>
+          </a:xfrm>
+          <a:prstGeom prst="rect">
+            <a:avLst/>
+          </a:prstGeom>
+          <a:noFill/>
+        </p:spPr>
+        <p:txBody>
+          <a:bodyPr wrap="square" lIns="0" rIns="0" tIns="0" bIns="0">
+            <a:spAutoFit/>
+          </a:bodyPr>
+          <a:lstStyle/>
+          <a:p>
+            <a:pPr>
+              <a:lnSpc>
+                <a:spcPct val="115000"/>
+              </a:lnSpc>
+            </a:pPr>
+            <a:r>
+              <a:rPr sz="1200" b="1">
+                <a:solidFill>
+                  <a:srgbClr val="595959"/>
+                </a:solidFill>
+                <a:latin typeface="Arial"/>
+              </a:rPr>
+              <a:t>4  ·  WHY DID PBO STILL RISE?</a:t>
+            </a:r>
+          </a:p>
+        </p:txBody>
+      </p:sp>
+      <p:sp>
+        <p:nvSpPr>
+          <p:cNvPr id="11" name="TextBox 10"/>
+          <p:cNvSpPr txBox="1"/>
+          <p:nvPr/>
+        </p:nvSpPr>
+        <p:spPr>
+          <a:xfrm>
+            <a:off x="670560" y="4425696"/>
+            <a:ext cx="10850879" cy="475488"/>
+          </a:xfrm>
+          <a:prstGeom prst="rect">
+            <a:avLst/>
+          </a:prstGeom>
+          <a:noFill/>
+        </p:spPr>
+        <p:txBody>
+          <a:bodyPr wrap="square" lIns="0" rIns="0" tIns="0" bIns="0">
+            <a:spAutoFit/>
+          </a:bodyPr>
+          <a:lstStyle/>
+          <a:p>
+            <a:pPr>
+              <a:lnSpc>
+                <a:spcPct val="125000"/>
+              </a:lnSpc>
+            </a:pPr>
+            <a:r>
+              <a:rPr sz="1400" b="0">
+                <a:solidFill>
+                  <a:srgbClr val="262626"/>
+                </a:solidFill>
+                <a:latin typeface="Arial"/>
+              </a:rPr>
+              <a:t>Marketing and supply chain cost by brand, against the Gross Profit they were meant to earn.</a:t>
+            </a:r>
+          </a:p>
+        </p:txBody>
+      </p:sp>
+      <p:sp>
+        <p:nvSpPr>
+          <p:cNvPr id="12" name="TextBox 11"/>
+          <p:cNvSpPr txBox="1"/>
+          <p:nvPr/>
+        </p:nvSpPr>
+        <p:spPr>
+          <a:xfrm>
+            <a:off x="670560" y="5010912"/>
+            <a:ext cx="10850879" cy="256032"/>
+          </a:xfrm>
+          <a:prstGeom prst="rect">
+            <a:avLst/>
+          </a:prstGeom>
+          <a:noFill/>
+        </p:spPr>
+        <p:txBody>
+          <a:bodyPr wrap="square" lIns="0" rIns="0" tIns="0" bIns="0">
+            <a:spAutoFit/>
+          </a:bodyPr>
+          <a:lstStyle/>
+          <a:p>
+            <a:pPr>
+              <a:lnSpc>
+                <a:spcPct val="115000"/>
+              </a:lnSpc>
+            </a:pPr>
+            <a:r>
+              <a:rPr sz="1200" b="1">
+                <a:solidFill>
+                  <a:srgbClr val="595959"/>
+                </a:solidFill>
+                <a:latin typeface="Arial"/>
+              </a:rPr>
+              <a:t>5  ·  WHAT IS LEFT TO GROW?</a:t>
+            </a:r>
+          </a:p>
+        </p:txBody>
+      </p:sp>
+      <p:sp>
+        <p:nvSpPr>
+          <p:cNvPr id="13" name="TextBox 12"/>
+          <p:cNvSpPr txBox="1"/>
+          <p:nvPr/>
+        </p:nvSpPr>
+        <p:spPr>
+          <a:xfrm>
+            <a:off x="670560" y="5266944"/>
+            <a:ext cx="10850879" cy="475488"/>
+          </a:xfrm>
+          <a:prstGeom prst="rect">
+            <a:avLst/>
+          </a:prstGeom>
+          <a:noFill/>
+        </p:spPr>
+        <p:txBody>
+          <a:bodyPr wrap="square" lIns="0" rIns="0" tIns="0" bIns="0">
+            <a:spAutoFit/>
+          </a:bodyPr>
+          <a:lstStyle/>
+          <a:p>
+            <a:pPr>
+              <a:lnSpc>
+                <a:spcPct val="125000"/>
+              </a:lnSpc>
+            </a:pPr>
+            <a:r>
+              <a:rPr sz="1400" b="0">
+                <a:solidFill>
+                  <a:srgbClr val="262626"/>
+                </a:solidFill>
+                <a:latin typeface="Arial"/>
+              </a:rPr>
+              <a:t>COBALT and SKY measured against their own markets, not against each other.</a:t>
+            </a:r>
+          </a:p>
+        </p:txBody>
+      </p:sp>
+      <p:sp>
+        <p:nvSpPr>
+          <p:cNvPr id="14" name="TextBox 13"/>
+          <p:cNvSpPr txBox="1"/>
+          <p:nvPr/>
+        </p:nvSpPr>
+        <p:spPr>
+          <a:xfrm>
+            <a:off x="670560" y="5852160"/>
+            <a:ext cx="10850879" cy="256032"/>
+          </a:xfrm>
+          <a:prstGeom prst="rect">
+            <a:avLst/>
+          </a:prstGeom>
+          <a:noFill/>
+        </p:spPr>
+        <p:txBody>
+          <a:bodyPr wrap="square" lIns="0" rIns="0" tIns="0" bIns="0">
+            <a:spAutoFit/>
+          </a:bodyPr>
+          <a:lstStyle/>
+          <a:p>
+            <a:pPr>
+              <a:lnSpc>
+                <a:spcPct val="115000"/>
+              </a:lnSpc>
+            </a:pPr>
+            <a:r>
+              <a:rPr sz="1200" b="1">
+                <a:solidFill>
+                  <a:srgbClr val="595959"/>
+                </a:solidFill>
+                <a:latin typeface="Arial"/>
+              </a:rPr>
+              <a:t>6  ·  WHAT WE ARE ASKING FOR</a:t>
+            </a:r>
+          </a:p>
+        </p:txBody>
+      </p:sp>
+      <p:sp>
+        <p:nvSpPr>
+          <p:cNvPr id="15" name="TextBox 14"/>
+          <p:cNvSpPr txBox="1"/>
+          <p:nvPr/>
+        </p:nvSpPr>
+        <p:spPr>
+          <a:xfrm>
+            <a:off x="670560" y="6108192"/>
+            <a:ext cx="10850879" cy="475488"/>
+          </a:xfrm>
+          <a:prstGeom prst="rect">
+            <a:avLst/>
+          </a:prstGeom>
+          <a:noFill/>
+        </p:spPr>
+        <p:txBody>
+          <a:bodyPr wrap="square" lIns="0" rIns="0" tIns="0" bIns="0">
+            <a:spAutoFit/>
+          </a:bodyPr>
+          <a:lstStyle/>
+          <a:p>
+            <a:pPr>
+              <a:lnSpc>
+                <a:spcPct val="125000"/>
+              </a:lnSpc>
+            </a:pPr>
+            <a:r>
+              <a:rPr sz="1400" b="0">
+                <a:solidFill>
+                  <a:srgbClr val="262626"/>
+                </a:solidFill>
+                <a:latin typeface="Arial"/>
+              </a:rPr>
+              <a:t>Three gated actions, each with a named owner and a decision due in week 0.</a:t>
+            </a:r>
+          </a:p>
+        </p:txBody>
+      </p:sp>
+      <p:sp>
+        <p:nvSpPr>
+          <p:cNvPr id="16" name="TextBox 15"/>
           <p:cNvSpPr txBox="1"/>
           <p:nvPr/>
         </p:nvSpPr>
@@ -5224,6 +6110,219 @@
 </file>
 
 <file path=ppt/slides/slide3.xml><?xml version="1.0" encoding="utf-8"?>
+<p:sld xmlns:a="http://schemas.openxmlformats.org/drawingml/2006/main" xmlns:p="http://schemas.openxmlformats.org/presentationml/2006/main" xmlns:r="http://schemas.openxmlformats.org/officeDocument/2006/relationships">
+  <p:cSld>
+    <p:spTree>
+      <p:nvGrpSpPr>
+        <p:cNvPr id="1" name=""/>
+        <p:cNvGrpSpPr/>
+        <p:nvPr/>
+      </p:nvGrpSpPr>
+      <p:grpSpPr/>
+      <p:sp>
+        <p:nvSpPr>
+          <p:cNvPr id="2" name="TextBox 1"/>
+          <p:cNvSpPr txBox="1"/>
+          <p:nvPr/>
+        </p:nvSpPr>
+        <p:spPr>
+          <a:xfrm>
+            <a:off x="670560" y="137160"/>
+            <a:ext cx="10850879" cy="228600"/>
+          </a:xfrm>
+          <a:prstGeom prst="rect">
+            <a:avLst/>
+          </a:prstGeom>
+          <a:noFill/>
+        </p:spPr>
+        <p:txBody>
+          <a:bodyPr wrap="square" lIns="0" rIns="0" tIns="0" bIns="0">
+            <a:spAutoFit/>
+          </a:bodyPr>
+          <a:lstStyle/>
+          <a:p>
+            <a:pPr>
+              <a:lnSpc>
+                <a:spcPct val="115000"/>
+              </a:lnSpc>
+            </a:pPr>
+            <a:r>
+              <a:rPr sz="950" b="1">
+                <a:solidFill>
+                  <a:srgbClr val="BFBFBF"/>
+                </a:solidFill>
+                <a:latin typeface="Arial"/>
+              </a:rPr>
+              <a:t>THE ANSWER, UP FRONT</a:t>
+            </a:r>
+          </a:p>
+        </p:txBody>
+      </p:sp>
+      <p:sp>
+        <p:nvSpPr>
+          <p:cNvPr id="3" name="TextBox 2"/>
+          <p:cNvSpPr txBox="1"/>
+          <p:nvPr/>
+        </p:nvSpPr>
+        <p:spPr>
+          <a:xfrm>
+            <a:off x="670560" y="411480"/>
+            <a:ext cx="10850879" cy="822960"/>
+          </a:xfrm>
+          <a:prstGeom prst="rect">
+            <a:avLst/>
+          </a:prstGeom>
+          <a:noFill/>
+        </p:spPr>
+        <p:txBody>
+          <a:bodyPr wrap="square" lIns="0" rIns="0" tIns="0" bIns="0">
+            <a:spAutoFit/>
+          </a:bodyPr>
+          <a:lstStyle/>
+          <a:p>
+            <a:pPr>
+              <a:lnSpc>
+                <a:spcPct val="115000"/>
+              </a:lnSpc>
+            </a:pPr>
+            <a:r>
+              <a:rPr sz="2300" b="1">
+                <a:solidFill>
+                  <a:srgbClr val="004C6D"/>
+                </a:solidFill>
+                <a:latin typeface="Arial"/>
+              </a:rPr>
+              <a:t>Profit rose, but the business did not get healthier</a:t>
+            </a:r>
+          </a:p>
+        </p:txBody>
+      </p:sp>
+      <p:sp>
+        <p:nvSpPr>
+          <p:cNvPr id="4" name="TextBox 3"/>
+          <p:cNvSpPr txBox="1"/>
+          <p:nvPr/>
+        </p:nvSpPr>
+        <p:spPr>
+          <a:xfrm>
+            <a:off x="670560" y="3063493"/>
+            <a:ext cx="10850879" cy="749808"/>
+          </a:xfrm>
+          <a:prstGeom prst="rect">
+            <a:avLst/>
+          </a:prstGeom>
+          <a:noFill/>
+        </p:spPr>
+        <p:txBody>
+          <a:bodyPr wrap="square" lIns="0" rIns="0" tIns="0" bIns="0">
+            <a:spAutoFit/>
+          </a:bodyPr>
+          <a:lstStyle/>
+          <a:p>
+            <a:pPr>
+              <a:lnSpc>
+                <a:spcPct val="130000"/>
+              </a:lnSpc>
+            </a:pPr>
+            <a:r>
+              <a:rPr sz="2600" b="1">
+                <a:solidFill>
+                  <a:srgbClr val="262626"/>
+                </a:solidFill>
+                <a:latin typeface="Arial"/>
+              </a:rPr>
+              <a:t>Topline and share fell. Lower spend alone protected PBO.</a:t>
+            </a:r>
+          </a:p>
+        </p:txBody>
+      </p:sp>
+      <p:sp>
+        <p:nvSpPr>
+          <p:cNvPr id="5" name="TextBox 4"/>
+          <p:cNvSpPr txBox="1"/>
+          <p:nvPr/>
+        </p:nvSpPr>
+        <p:spPr>
+          <a:xfrm>
+            <a:off x="670560" y="3876802"/>
+            <a:ext cx="10850879" cy="731520"/>
+          </a:xfrm>
+          <a:prstGeom prst="rect">
+            <a:avLst/>
+          </a:prstGeom>
+          <a:noFill/>
+        </p:spPr>
+        <p:txBody>
+          <a:bodyPr wrap="square" lIns="0" rIns="0" tIns="0" bIns="0">
+            <a:spAutoFit/>
+          </a:bodyPr>
+          <a:lstStyle/>
+          <a:p>
+            <a:pPr>
+              <a:lnSpc>
+                <a:spcPct val="145000"/>
+              </a:lnSpc>
+            </a:pPr>
+            <a:r>
+              <a:rPr sz="1300" b="0">
+                <a:solidFill>
+                  <a:srgbClr val="595959"/>
+                </a:solidFill>
+                <a:latin typeface="Arial"/>
+              </a:rPr>
+              <a:t>Restore profitable growth without giving back the protected profit.</a:t>
+            </a:r>
+          </a:p>
+        </p:txBody>
+      </p:sp>
+      <p:sp>
+        <p:nvSpPr>
+          <p:cNvPr id="6" name="TextBox 5"/>
+          <p:cNvSpPr txBox="1"/>
+          <p:nvPr/>
+        </p:nvSpPr>
+        <p:spPr>
+          <a:xfrm>
+            <a:off x="670560" y="6469380"/>
+            <a:ext cx="10850879" cy="182880"/>
+          </a:xfrm>
+          <a:prstGeom prst="rect">
+            <a:avLst/>
+          </a:prstGeom>
+          <a:noFill/>
+        </p:spPr>
+        <p:txBody>
+          <a:bodyPr wrap="square" lIns="0" rIns="0" tIns="0" bIns="0">
+            <a:spAutoFit/>
+          </a:bodyPr>
+          <a:lstStyle/>
+          <a:p>
+            <a:pPr>
+              <a:lnSpc>
+                <a:spcPct val="115000"/>
+              </a:lnSpc>
+            </a:pPr>
+            <a:r>
+              <a:rPr sz="850" b="0">
+                <a:solidFill>
+                  <a:srgbClr val="BFBFBF"/>
+                </a:solidFill>
+                <a:latin typeface="Arial"/>
+              </a:rPr>
+              <a:t>Source: outputs/sales_master.csv, P&amp;L Table.xlsx and Market Report MAT Nov'24.xlsx</a:t>
+            </a:r>
+          </a:p>
+        </p:txBody>
+      </p:sp>
+    </p:spTree>
+  </p:cSld>
+  <p:clrMapOvr>
+    <a:masterClrMapping/>
+  </p:clrMapOvr>
+</p:sld>
+</file>
+
+<file path=ppt/slides/slide4.xml><?xml version="1.0" encoding="utf-8"?>
 <p:sld xmlns:a="http://schemas.openxmlformats.org/drawingml/2006/main" xmlns:p="http://schemas.openxmlformats.org/presentationml/2006/main" xmlns:r="http://schemas.openxmlformats.org/officeDocument/2006/relationships">
   <p:cSld>
     <p:spTree>
@@ -5421,7 +6520,7 @@
 </p:sld>
 </file>
 
-<file path=ppt/slides/slide4.xml><?xml version="1.0" encoding="utf-8"?>
+<file path=ppt/slides/slide5.xml><?xml version="1.0" encoding="utf-8"?>
 <p:sld xmlns:a="http://schemas.openxmlformats.org/drawingml/2006/main" xmlns:p="http://schemas.openxmlformats.org/presentationml/2006/main" xmlns:r="http://schemas.openxmlformats.org/officeDocument/2006/relationships">
   <p:cSld>
     <p:spTree>
@@ -5619,7 +6718,7 @@
 </p:sld>
 </file>
 
-<file path=ppt/slides/slide5.xml><?xml version="1.0" encoding="utf-8"?>
+<file path=ppt/slides/slide6.xml><?xml version="1.0" encoding="utf-8"?>
 <p:sld xmlns:a="http://schemas.openxmlformats.org/drawingml/2006/main" xmlns:p="http://schemas.openxmlformats.org/presentationml/2006/main" xmlns:r="http://schemas.openxmlformats.org/officeDocument/2006/relationships">
   <p:cSld>
     <p:spTree>
@@ -5817,7 +6916,7 @@
 </p:sld>
 </file>
 
-<file path=ppt/slides/slide6.xml><?xml version="1.0" encoding="utf-8"?>
+<file path=ppt/slides/slide7.xml><?xml version="1.0" encoding="utf-8"?>
 <p:sld xmlns:a="http://schemas.openxmlformats.org/drawingml/2006/main" xmlns:p="http://schemas.openxmlformats.org/presentationml/2006/main" xmlns:r="http://schemas.openxmlformats.org/officeDocument/2006/relationships">
   <p:cSld>
     <p:spTree>
@@ -6015,7 +7114,7 @@
 </p:sld>
 </file>
 
-<file path=ppt/slides/slide7.xml><?xml version="1.0" encoding="utf-8"?>
+<file path=ppt/slides/slide8.xml><?xml version="1.0" encoding="utf-8"?>
 <p:sld xmlns:a="http://schemas.openxmlformats.org/drawingml/2006/main" xmlns:p="http://schemas.openxmlformats.org/presentationml/2006/main" xmlns:r="http://schemas.openxmlformats.org/officeDocument/2006/relationships">
   <p:cSld>
     <p:spTree>
@@ -6213,7 +7312,7 @@
 </p:sld>
 </file>
 
-<file path=ppt/slides/slide8.xml><?xml version="1.0" encoding="utf-8"?>
+<file path=ppt/slides/slide9.xml><?xml version="1.0" encoding="utf-8"?>
 <p:sld xmlns:a="http://schemas.openxmlformats.org/drawingml/2006/main" xmlns:p="http://schemas.openxmlformats.org/presentationml/2006/main" xmlns:r="http://schemas.openxmlformats.org/officeDocument/2006/relationships">
   <p:cSld>
     <p:spTree>
@@ -6399,453 +7498,6 @@
                 <a:latin typeface="Arial"/>
               </a:rPr>
               <a:t>Source: P&amp;L Table.xlsx and Market Report MAT Nov'24.xlsx  |  Internal Turnover is FY sell-in; market value is MAT Nov'24 sell-out - different periods and different measures</a:t>
-            </a:r>
-          </a:p>
-        </p:txBody>
-      </p:sp>
-    </p:spTree>
-  </p:cSld>
-  <p:clrMapOvr>
-    <a:masterClrMapping/>
-  </p:clrMapOvr>
-</p:sld>
-</file>
-
-<file path=ppt/slides/slide9.xml><?xml version="1.0" encoding="utf-8"?>
-<p:sld xmlns:a="http://schemas.openxmlformats.org/drawingml/2006/main" xmlns:p="http://schemas.openxmlformats.org/presentationml/2006/main" xmlns:r="http://schemas.openxmlformats.org/officeDocument/2006/relationships">
-  <p:cSld>
-    <p:spTree>
-      <p:nvGrpSpPr>
-        <p:cNvPr id="1" name=""/>
-        <p:cNvGrpSpPr/>
-        <p:nvPr/>
-      </p:nvGrpSpPr>
-      <p:grpSpPr/>
-      <p:sp>
-        <p:nvSpPr>
-          <p:cNvPr id="2" name="TextBox 1"/>
-          <p:cNvSpPr txBox="1"/>
-          <p:nvPr/>
-        </p:nvSpPr>
-        <p:spPr>
-          <a:xfrm>
-            <a:off x="670560" y="137160"/>
-            <a:ext cx="10850879" cy="228600"/>
-          </a:xfrm>
-          <a:prstGeom prst="rect">
-            <a:avLst/>
-          </a:prstGeom>
-          <a:noFill/>
-        </p:spPr>
-        <p:txBody>
-          <a:bodyPr wrap="square" lIns="0" rIns="0" tIns="0" bIns="0">
-            <a:spAutoFit/>
-          </a:bodyPr>
-          <a:lstStyle/>
-          <a:p>
-            <a:pPr>
-              <a:lnSpc>
-                <a:spcPct val="115000"/>
-              </a:lnSpc>
-            </a:pPr>
-            <a:r>
-              <a:rPr sz="950" b="1">
-                <a:solidFill>
-                  <a:srgbClr val="BFBFBF"/>
-                </a:solidFill>
-                <a:latin typeface="Arial"/>
-              </a:rPr>
-              <a:t>THE ASK</a:t>
-            </a:r>
-          </a:p>
-        </p:txBody>
-      </p:sp>
-      <p:sp>
-        <p:nvSpPr>
-          <p:cNvPr id="3" name="TextBox 2"/>
-          <p:cNvSpPr txBox="1"/>
-          <p:nvPr/>
-        </p:nvSpPr>
-        <p:spPr>
-          <a:xfrm>
-            <a:off x="670560" y="411480"/>
-            <a:ext cx="10850879" cy="822960"/>
-          </a:xfrm>
-          <a:prstGeom prst="rect">
-            <a:avLst/>
-          </a:prstGeom>
-          <a:noFill/>
-        </p:spPr>
-        <p:txBody>
-          <a:bodyPr wrap="square" lIns="0" rIns="0" tIns="0" bIns="0">
-            <a:spAutoFit/>
-          </a:bodyPr>
-          <a:lstStyle/>
-          <a:p>
-            <a:pPr>
-              <a:lnSpc>
-                <a:spcPct val="115000"/>
-              </a:lnSpc>
-            </a:pPr>
-            <a:r>
-              <a:rPr sz="2300" b="1">
-                <a:solidFill>
-                  <a:srgbClr val="004C6D"/>
-                </a:solidFill>
-                <a:latin typeface="Arial"/>
-              </a:rPr>
-              <a:t>Approve the three week-0 gates today</a:t>
-            </a:r>
-          </a:p>
-        </p:txBody>
-      </p:sp>
-      <p:sp>
-        <p:nvSpPr>
-          <p:cNvPr id="4" name="TextBox 3"/>
-          <p:cNvSpPr txBox="1"/>
-          <p:nvPr/>
-        </p:nvSpPr>
-        <p:spPr>
-          <a:xfrm>
-            <a:off x="670560" y="1645919"/>
-            <a:ext cx="10850879" cy="256032"/>
-          </a:xfrm>
-          <a:prstGeom prst="rect">
-            <a:avLst/>
-          </a:prstGeom>
-          <a:noFill/>
-        </p:spPr>
-        <p:txBody>
-          <a:bodyPr wrap="square" lIns="0" rIns="0" tIns="0" bIns="0">
-            <a:spAutoFit/>
-          </a:bodyPr>
-          <a:lstStyle/>
-          <a:p>
-            <a:pPr>
-              <a:lnSpc>
-                <a:spcPct val="115000"/>
-              </a:lnSpc>
-            </a:pPr>
-            <a:r>
-              <a:rPr sz="1200" b="1">
-                <a:solidFill>
-                  <a:srgbClr val="004C6D"/>
-                </a:solidFill>
-                <a:latin typeface="Arial"/>
-              </a:rPr>
-              <a:t>ACTION 1  ·  SALES HEAD</a:t>
-            </a:r>
-          </a:p>
-        </p:txBody>
-      </p:sp>
-      <p:sp>
-        <p:nvSpPr>
-          <p:cNvPr id="5" name="TextBox 4"/>
-          <p:cNvSpPr txBox="1"/>
-          <p:nvPr/>
-        </p:nvSpPr>
-        <p:spPr>
-          <a:xfrm>
-            <a:off x="670560" y="1901952"/>
-            <a:ext cx="10850879" cy="475488"/>
-          </a:xfrm>
-          <a:prstGeom prst="rect">
-            <a:avLst/>
-          </a:prstGeom>
-          <a:noFill/>
-        </p:spPr>
-        <p:txBody>
-          <a:bodyPr wrap="square" lIns="0" rIns="0" tIns="0" bIns="0">
-            <a:spAutoFit/>
-          </a:bodyPr>
-          <a:lstStyle/>
-          <a:p>
-            <a:pPr>
-              <a:lnSpc>
-                <a:spcPct val="125000"/>
-              </a:lnSpc>
-            </a:pPr>
-            <a:r>
-              <a:rPr sz="1400" b="0">
-                <a:solidFill>
-                  <a:srgbClr val="262626"/>
-                </a:solidFill>
-                <a:latin typeface="Arial"/>
-              </a:rPr>
-              <a:t>Approve the OLIVE × Modern Trade recovery baseline and its customer × SKU economics, weeks 0-2.</a:t>
-            </a:r>
-          </a:p>
-        </p:txBody>
-      </p:sp>
-      <p:sp>
-        <p:nvSpPr>
-          <p:cNvPr id="6" name="TextBox 5"/>
-          <p:cNvSpPr txBox="1"/>
-          <p:nvPr/>
-        </p:nvSpPr>
-        <p:spPr>
-          <a:xfrm>
-            <a:off x="670560" y="2487168"/>
-            <a:ext cx="10850879" cy="256032"/>
-          </a:xfrm>
-          <a:prstGeom prst="rect">
-            <a:avLst/>
-          </a:prstGeom>
-          <a:noFill/>
-        </p:spPr>
-        <p:txBody>
-          <a:bodyPr wrap="square" lIns="0" rIns="0" tIns="0" bIns="0">
-            <a:spAutoFit/>
-          </a:bodyPr>
-          <a:lstStyle/>
-          <a:p>
-            <a:pPr>
-              <a:lnSpc>
-                <a:spcPct val="115000"/>
-              </a:lnSpc>
-            </a:pPr>
-            <a:r>
-              <a:rPr sz="1200" b="1">
-                <a:solidFill>
-                  <a:srgbClr val="004C6D"/>
-                </a:solidFill>
-                <a:latin typeface="Arial"/>
-              </a:rPr>
-              <a:t>ACTION 2  ·  SALES HEAD</a:t>
-            </a:r>
-          </a:p>
-        </p:txBody>
-      </p:sp>
-      <p:sp>
-        <p:nvSpPr>
-          <p:cNvPr id="7" name="TextBox 6"/>
-          <p:cNvSpPr txBox="1"/>
-          <p:nvPr/>
-        </p:nvSpPr>
-        <p:spPr>
-          <a:xfrm>
-            <a:off x="670560" y="2743200"/>
-            <a:ext cx="10850879" cy="475488"/>
-          </a:xfrm>
-          <a:prstGeom prst="rect">
-            <a:avLst/>
-          </a:prstGeom>
-          <a:noFill/>
-        </p:spPr>
-        <p:txBody>
-          <a:bodyPr wrap="square" lIns="0" rIns="0" tIns="0" bIns="0">
-            <a:spAutoFit/>
-          </a:bodyPr>
-          <a:lstStyle/>
-          <a:p>
-            <a:pPr>
-              <a:lnSpc>
-                <a:spcPct val="125000"/>
-              </a:lnSpc>
-            </a:pPr>
-            <a:r>
-              <a:rPr sz="1400" b="0">
-                <a:solidFill>
-                  <a:srgbClr val="262626"/>
-                </a:solidFill>
-                <a:latin typeface="Arial"/>
-              </a:rPr>
-              <a:t>Approve classifying trade spend into keep, test, redesign or stop before any budget is restored.</a:t>
-            </a:r>
-          </a:p>
-        </p:txBody>
-      </p:sp>
-      <p:sp>
-        <p:nvSpPr>
-          <p:cNvPr id="8" name="TextBox 7"/>
-          <p:cNvSpPr txBox="1"/>
-          <p:nvPr/>
-        </p:nvSpPr>
-        <p:spPr>
-          <a:xfrm>
-            <a:off x="670560" y="3328415"/>
-            <a:ext cx="10850879" cy="256032"/>
-          </a:xfrm>
-          <a:prstGeom prst="rect">
-            <a:avLst/>
-          </a:prstGeom>
-          <a:noFill/>
-        </p:spPr>
-        <p:txBody>
-          <a:bodyPr wrap="square" lIns="0" rIns="0" tIns="0" bIns="0">
-            <a:spAutoFit/>
-          </a:bodyPr>
-          <a:lstStyle/>
-          <a:p>
-            <a:pPr>
-              <a:lnSpc>
-                <a:spcPct val="115000"/>
-              </a:lnSpc>
-            </a:pPr>
-            <a:r>
-              <a:rPr sz="1200" b="1">
-                <a:solidFill>
-                  <a:srgbClr val="004C6D"/>
-                </a:solidFill>
-                <a:latin typeface="Arial"/>
-              </a:rPr>
-              <a:t>ACTION 3  ·  FINANCE HEAD</a:t>
-            </a:r>
-          </a:p>
-        </p:txBody>
-      </p:sp>
-      <p:sp>
-        <p:nvSpPr>
-          <p:cNvPr id="9" name="TextBox 8"/>
-          <p:cNvSpPr txBox="1"/>
-          <p:nvPr/>
-        </p:nvSpPr>
-        <p:spPr>
-          <a:xfrm>
-            <a:off x="670560" y="3584448"/>
-            <a:ext cx="10850879" cy="475488"/>
-          </a:xfrm>
-          <a:prstGeom prst="rect">
-            <a:avLst/>
-          </a:prstGeom>
-          <a:noFill/>
-        </p:spPr>
-        <p:txBody>
-          <a:bodyPr wrap="square" lIns="0" rIns="0" tIns="0" bIns="0">
-            <a:spAutoFit/>
-          </a:bodyPr>
-          <a:lstStyle/>
-          <a:p>
-            <a:pPr>
-              <a:lnSpc>
-                <a:spcPct val="125000"/>
-              </a:lnSpc>
-            </a:pPr>
-            <a:r>
-              <a:rPr sz="1400" b="0">
-                <a:solidFill>
-                  <a:srgbClr val="262626"/>
-                </a:solidFill>
-                <a:latin typeface="Arial"/>
-              </a:rPr>
-              <a:t>Agree scale funding is released only after positive incremental Gross Profit — COBALT first, SKY only after diagnosis.</a:t>
-            </a:r>
-          </a:p>
-        </p:txBody>
-      </p:sp>
-      <p:sp>
-        <p:nvSpPr>
-          <p:cNvPr id="10" name="TextBox 9"/>
-          <p:cNvSpPr txBox="1"/>
-          <p:nvPr/>
-        </p:nvSpPr>
-        <p:spPr>
-          <a:xfrm>
-            <a:off x="670560" y="4169664"/>
-            <a:ext cx="10850879" cy="256032"/>
-          </a:xfrm>
-          <a:prstGeom prst="rect">
-            <a:avLst/>
-          </a:prstGeom>
-          <a:noFill/>
-        </p:spPr>
-        <p:txBody>
-          <a:bodyPr wrap="square" lIns="0" rIns="0" tIns="0" bIns="0">
-            <a:spAutoFit/>
-          </a:bodyPr>
-          <a:lstStyle/>
-          <a:p>
-            <a:pPr>
-              <a:lnSpc>
-                <a:spcPct val="115000"/>
-              </a:lnSpc>
-            </a:pPr>
-            <a:r>
-              <a:rPr sz="1200" b="1">
-                <a:solidFill>
-                  <a:srgbClr val="004C6D"/>
-                </a:solidFill>
-                <a:latin typeface="Arial"/>
-              </a:rPr>
-              <a:t>IF WE DO NOTHING</a:t>
-            </a:r>
-          </a:p>
-        </p:txBody>
-      </p:sp>
-      <p:sp>
-        <p:nvSpPr>
-          <p:cNvPr id="11" name="TextBox 10"/>
-          <p:cNvSpPr txBox="1"/>
-          <p:nvPr/>
-        </p:nvSpPr>
-        <p:spPr>
-          <a:xfrm>
-            <a:off x="670560" y="4425696"/>
-            <a:ext cx="10850879" cy="475488"/>
-          </a:xfrm>
-          <a:prstGeom prst="rect">
-            <a:avLst/>
-          </a:prstGeom>
-          <a:noFill/>
-        </p:spPr>
-        <p:txBody>
-          <a:bodyPr wrap="square" lIns="0" rIns="0" tIns="0" bIns="0">
-            <a:spAutoFit/>
-          </a:bodyPr>
-          <a:lstStyle/>
-          <a:p>
-            <a:pPr>
-              <a:lnSpc>
-                <a:spcPct val="125000"/>
-              </a:lnSpc>
-            </a:pPr>
-            <a:r>
-              <a:rPr sz="1400" b="0">
-                <a:solidFill>
-                  <a:srgbClr val="262626"/>
-                </a:solidFill>
-                <a:latin typeface="Arial"/>
-              </a:rPr>
-              <a:t>The marketing lever cannot be pulled twice; FY2025 PBO carries the full topline decline.</a:t>
-            </a:r>
-          </a:p>
-        </p:txBody>
-      </p:sp>
-      <p:sp>
-        <p:nvSpPr>
-          <p:cNvPr id="12" name="TextBox 11"/>
-          <p:cNvSpPr txBox="1"/>
-          <p:nvPr/>
-        </p:nvSpPr>
-        <p:spPr>
-          <a:xfrm>
-            <a:off x="670560" y="6469380"/>
-            <a:ext cx="10850879" cy="182880"/>
-          </a:xfrm>
-          <a:prstGeom prst="rect">
-            <a:avLst/>
-          </a:prstGeom>
-          <a:noFill/>
-        </p:spPr>
-        <p:txBody>
-          <a:bodyPr wrap="square" lIns="0" rIns="0" tIns="0" bIns="0">
-            <a:spAutoFit/>
-          </a:bodyPr>
-          <a:lstStyle/>
-          <a:p>
-            <a:pPr>
-              <a:lnSpc>
-                <a:spcPct val="115000"/>
-              </a:lnSpc>
-            </a:pPr>
-            <a:r>
-              <a:rPr sz="850" b="0">
-                <a:solidFill>
-                  <a:srgbClr val="BFBFBF"/>
-                </a:solidFill>
-                <a:latin typeface="Arial"/>
-              </a:rPr>
-              <a:t>Source: references/domain/calls-to-action-by-audience.md</a:t>
             </a:r>
           </a:p>
         </p:txBody>

</xml_diff>